<commit_message>
Faktakoll och språkkoll område 1: rättade Semmelweis-kvot, slump/systematiskt fel, oklara siffror; Lässtöd på sajten
Co-Authored-By: Claude Sonnet 5.5 <noreply@anthropic.com>
Claude-Session: https://claude.ai/code/session_017mqJrSEX6tzqa8YfkctM6P
</commit_message>
<xml_diff>
--- a/planering/biologi-omrade1/biologi-1-0-introduktion-till-biologi.pptx
+++ b/planering/biologi-omrade1/biologi-1-0-introduktion-till-biologi.pptx
@@ -114,12 +114,12 @@
   <p:extLst>
     <p:ext uri="{521415D9-36F7-43E2-AB2F-B90AF26B5E84}">
       <p14:sectionLst xmlns:p14="http://schemas.microsoft.com/office/powerpoint/2010/main">
-        <p14:section name="Start" id="{bfb7d0f8-a413-d30f-5f1b-b25ade7e589d}">
+        <p14:section name="Start" id="{f91c8a36-1eb2-f700-5fa7-abff8141c752}">
           <p14:sldIdLst>
             <p14:sldId id="256"/>
           </p14:sldIdLst>
         </p14:section>
-        <p14:section name="Introduktion till biologi" id="{d5d8d0d8-6dd4-d818-f20e-83b110112874}">
+        <p14:section name="Introduktion till biologi" id="{faf9cccf-2b77-cc2a-ea18-7072447559ff}">
           <p14:sldIdLst>
             <p14:sldId id="257"/>
             <p14:sldId id="258"/>

</xml_diff>

<commit_message>
Område 1: märkt påhittade exempel, sajt och PDF matchar (sammanfattning, begrepp, test), dyslexivänlig typografi i PDF och sajt
Co-Authored-By: Claude Sonnet 5.5 <noreply@anthropic.com>
Claude-Session: https://claude.ai/code/session_017mqJrSEX6tzqa8YfkctM6P
</commit_message>
<xml_diff>
--- a/planering/biologi-omrade1/biologi-1-0-introduktion-till-biologi.pptx
+++ b/planering/biologi-omrade1/biologi-1-0-introduktion-till-biologi.pptx
@@ -114,12 +114,12 @@
   <p:extLst>
     <p:ext uri="{521415D9-36F7-43E2-AB2F-B90AF26B5E84}">
       <p14:sectionLst xmlns:p14="http://schemas.microsoft.com/office/powerpoint/2010/main">
-        <p14:section name="Start" id="{f91c8a36-1eb2-f700-5fa7-abff8141c752}">
+        <p14:section name="Start" id="{0e034108-9ff0-07c9-c002-e6a5d49881cb}">
           <p14:sldIdLst>
             <p14:sldId id="256"/>
           </p14:sldIdLst>
         </p14:section>
-        <p14:section name="Introduktion till biologi" id="{faf9cccf-2b77-cc2a-ea18-7072447559ff}">
+        <p14:section name="Introduktion till biologi" id="{43bc3abd-d02e-9f72-118b-b7d72a59d89f}">
           <p14:sldIdLst>
             <p14:sldId id="257"/>
             <p14:sldId id="258"/>

</xml_diff>

<commit_message>
Område 1: ta bort momentnumren (1.1.1 osv.), moment heter sina namn; kapitel och delområde behåller nummer
Co-Authored-By: Claude Sonnet 5.5 <noreply@anthropic.com>
Claude-Session: https://claude.ai/code/session_017mqJrSEX6tzqa8YfkctM6P
</commit_message>
<xml_diff>
--- a/planering/biologi-omrade1/biologi-1-0-introduktion-till-biologi.pptx
+++ b/planering/biologi-omrade1/biologi-1-0-introduktion-till-biologi.pptx
@@ -114,12 +114,12 @@
   <p:extLst>
     <p:ext uri="{521415D9-36F7-43E2-AB2F-B90AF26B5E84}">
       <p14:sectionLst xmlns:p14="http://schemas.microsoft.com/office/powerpoint/2010/main">
-        <p14:section name="Start" id="{0e034108-9ff0-07c9-c002-e6a5d49881cb}">
+        <p14:section name="Start" id="{15d47735-a954-a465-97d4-77be8924d682}">
           <p14:sldIdLst>
             <p14:sldId id="256"/>
           </p14:sldIdLst>
         </p14:section>
-        <p14:section name="Introduktion till biologi" id="{43bc3abd-d02e-9f72-118b-b7d72a59d89f}">
+        <p14:section name="Introduktion till biologi" id="{e2c532a0-cfdd-6575-7853-dba418ec0723}">
           <p14:sldIdLst>
             <p14:sldId id="257"/>
             <p14:sldId id="258"/>

</xml_diff>

<commit_message>
Ta bort veckor och tider ur planering, lärarvy och material; illustrationer i provet; gröna paletten på biologisidor och lärarvy
Co-Authored-By: Claude Sonnet 5.5 <noreply@anthropic.com>
Claude-Session: https://claude.ai/code/session_017mqJrSEX6tzqa8YfkctM6P
</commit_message>
<xml_diff>
--- a/planering/biologi-omrade1/biologi-1-0-introduktion-till-biologi.pptx
+++ b/planering/biologi-omrade1/biologi-1-0-introduktion-till-biologi.pptx
@@ -114,12 +114,12 @@
   <p:extLst>
     <p:ext uri="{521415D9-36F7-43E2-AB2F-B90AF26B5E84}">
       <p14:sectionLst xmlns:p14="http://schemas.microsoft.com/office/powerpoint/2010/main">
-        <p14:section name="Start" id="{15d47735-a954-a465-97d4-77be8924d682}">
+        <p14:section name="Start" id="{33f0190a-047a-0d84-fd92-ee5d49fa3689}">
           <p14:sldIdLst>
             <p14:sldId id="256"/>
           </p14:sldIdLst>
         </p14:section>
-        <p14:section name="Introduktion till biologi" id="{e2c532a0-cfdd-6575-7853-dba418ec0723}">
+        <p14:section name="Introduktion till biologi" id="{8d477f27-bf5e-d0b9-0b5d-1c2b2e6a5868}">
           <p14:sldIdLst>
             <p14:sldId id="257"/>
             <p14:sldId id="258"/>
@@ -534,7 +534,7 @@
           <a:p>
             <a:r>
               <a:rPr lang="en-US" dirty="0"/>
-              <a:t>Kort startlektion (ca 30–40 min) som följer avsnittet Start i grundtexten, före delområde 1.1. Anteckningarna innehåller handledning.</a:t>
+              <a:t>Kort startlektion som följer avsnittet Start i grundtexten, före delområde 1.1. Anteckningarna innehåller handledning.</a:t>
             </a:r>
             <a:endParaRPr lang="en-US" dirty="0"/>
           </a:p>

</xml_diff>